<commit_message>
feat(brand+dashboard): Autonomi deck rebrand v7.26.0 + Live App iframe boot-window fix
Deck: Autonomi's Loki Mode branding, agent-roles/domains framing, provider
tiering honesty, Autonomi Cloud coming-soon line; GIF regenerated (11 frames
verified). Dashboard: include last_health.ok in the preview change-hash so the
iframe reloads when the app transitions to actually-serving (observed on a
real compose stack: iframe loaded during the boot window stayed blank forever).
</commit_message>
<xml_diff>
--- a/docs/loki-mode-presentation.pptx
+++ b/docs/loki-mode-presentation.pptx
@@ -1914,7 +1914,7 @@
                 <a:ea typeface="Inter" pitchFamily="34" charset="-122"/>
                 <a:cs typeface="Inter" pitchFamily="34" charset="-120"/>
               </a:rPr>
-              <a:t>Loki Mode</a:t>
+              <a:t>Autonomi's Loki Mode</a:t>
             </a:r>
             <a:endParaRPr lang="en-US" sz="4353" dirty="0"/>
           </a:p>
@@ -1928,7 +1928,7 @@
         </p:nvSpPr>
         <p:spPr>
           <a:xfrm>
-            <a:off x="450056" y="2556318"/>
+            <a:off x="450056" y="3108960"/>
             <a:ext cx="3571875" cy="840088"/>
           </a:xfrm>
           <a:prstGeom prst="rect">
@@ -2037,7 +2037,7 @@
                 <a:ea typeface="JetBrains Mono" pitchFamily="34" charset="-122"/>
                 <a:cs typeface="JetBrains Mono" pitchFamily="34" charset="-120"/>
               </a:rPr>
-              <a:t> Powered by Autonomi (v7.24.0)</a:t>
+              <a:t> Powered by Autonomi (v7.26.0)</a:t>
             </a:r>
             <a:endParaRPr lang="en-US" sz="834" dirty="0"/>
           </a:p>
@@ -2495,7 +2495,7 @@
                 <a:ea typeface="JetBrains Mono" pitchFamily="34" charset="-122"/>
                 <a:cs typeface="JetBrains Mono" pitchFamily="34" charset="-120"/>
               </a:rPr>
-              <a:t>v7.24.0</a:t>
+              <a:t>v7.26.0</a:t>
             </a:r>
             <a:endParaRPr lang="en-US" sz="727" dirty="0"/>
           </a:p>
@@ -3801,7 +3801,7 @@
                 <a:ea typeface="Inter" pitchFamily="34" charset="-122"/>
                 <a:cs typeface="Inter" pitchFamily="34" charset="-120"/>
               </a:rPr>
-              <a:t>Loki Mode v7.24.0 is the most advanced autonomous framework for production software delivery. Join the Autonomi revolution and ship better code, faster.</a:t>
+              <a:t>Autonomi's Loki Mode v7.26.0 is the most advanced autonomous framework for production software delivery. Join the Autonomi revolution and ship better code, faster.</a:t>
             </a:r>
             <a:endParaRPr lang="en-US" sz="1269" dirty="0"/>
           </a:p>
@@ -3938,6 +3938,50 @@
                 <a:cs typeface="Inter" pitchFamily="34" charset="-120"/>
               </a:rPr>
               <a:t>github.com/asklokesh/loki-mode</a:t>
+            </a:r>
+            <a:endParaRPr lang="en-US" sz="885" dirty="0"/>
+          </a:p>
+        </p:txBody>
+      </p:sp>
+      <p:sp>
+        <p:nvSpPr>
+          <p:cNvPr id="17" name="Text 17"/>
+          <p:cNvSpPr/>
+          <p:nvPr/>
+        </p:nvSpPr>
+        <p:spPr>
+          <a:xfrm>
+            <a:off x="761228" y="4076916"/>
+            <a:ext cx="2094905" cy="155377"/>
+          </a:xfrm>
+          <a:prstGeom prst="rect">
+            <a:avLst/>
+          </a:prstGeom>
+          <a:noFill/>
+          <a:ln/>
+        </p:spPr>
+        <p:txBody>
+          <a:bodyPr wrap="none" lIns="0" tIns="0" rIns="0" bIns="0" rtlCol="0" anchor="t">
+            <a:spAutoFit/>
+          </a:bodyPr>
+          <a:lstStyle/>
+          <a:p>
+            <a:pPr algn="l" indent="0" marL="0">
+              <a:lnSpc>
+                <a:spcPts val="1200"/>
+              </a:lnSpc>
+              <a:buNone/>
+            </a:pPr>
+            <a:r>
+              <a:rPr lang="en-US" sz="885" b="1" dirty="0">
+                <a:solidFill>
+                  <a:srgbClr val="6366F1"/>
+                </a:solidFill>
+                <a:latin typeface="Inter" pitchFamily="34" charset="0"/>
+                <a:ea typeface="Inter" pitchFamily="34" charset="-122"/>
+                <a:cs typeface="Inter" pitchFamily="34" charset="-120"/>
+              </a:rPr>
+              <a:t>Autonomi Cloud - coming soon</a:t>
             </a:r>
             <a:endParaRPr lang="en-US" sz="885" dirty="0"/>
           </a:p>
@@ -4273,7 +4317,7 @@
                 <a:ea typeface="JetBrains Mono" pitchFamily="34" charset="-122"/>
                 <a:cs typeface="JetBrains Mono" pitchFamily="34" charset="-120"/>
               </a:rPr>
-              <a:t> # 41 Agents | Concurrent Session #1</a:t>
+              <a:t> # 41 Agent Roles | Concurrent Session #1</a:t>
             </a:r>
             <a:pPr algn="l" indent="0" marL="0">
               <a:lnSpc>
@@ -4308,7 +4352,7 @@
                 <a:ea typeface="JetBrains Mono" pitchFamily="34" charset="-122"/>
                 <a:cs typeface="JetBrains Mono" pitchFamily="34" charset="-120"/>
               </a:rPr>
-              <a:t> # Quality Gates: v7.24.0 Ready</a:t>
+              <a:t> # Quality Gates: v7.26.0 Ready</a:t>
             </a:r>
             <a:endParaRPr lang="en-US" sz="727" dirty="0"/>
           </a:p>
@@ -4845,7 +4889,7 @@
                 <a:ea typeface="Inter" pitchFamily="34" charset="-122"/>
                 <a:cs typeface="Inter" pitchFamily="34" charset="-120"/>
               </a:rPr>
-              <a:t>Orchestrates 41 specialized AI agents across 8 swarms for full-lifecycle delivery.</a:t>
+              <a:t>Orchestrates 41 specialized agent roles across 8 domains for full-lifecycle delivery.</a:t>
             </a:r>
             <a:endParaRPr lang="en-US" sz="942" dirty="0"/>
           </a:p>
@@ -5239,7 +5283,7 @@
                 <a:ea typeface="Inter" pitchFamily="34" charset="-122"/>
                 <a:cs typeface="Inter" pitchFamily="34" charset="-120"/>
               </a:rPr>
-              <a:t>Framework Architecture: 8 Swarms</a:t>
+              <a:t>Framework Architecture: 8 Domains</a:t>
             </a:r>
             <a:endParaRPr lang="en-US" sz="2436" dirty="0"/>
           </a:p>
@@ -5283,7 +5327,7 @@
                 <a:ea typeface="Inter" pitchFamily="34" charset="-122"/>
                 <a:cs typeface="Inter" pitchFamily="34" charset="-120"/>
               </a:rPr>
-              <a:t>SWARM</a:t>
+              <a:t>DOMAIN</a:t>
             </a:r>
             <a:endParaRPr lang="en-US" sz="885" dirty="0"/>
           </a:p>
@@ -9755,7 +9799,7 @@
                 <a:ea typeface="Inter" pitchFamily="34" charset="-122"/>
                 <a:cs typeface="Inter" pitchFamily="34" charset="-120"/>
               </a:rPr>
-              <a:t>4-PROVIDER ERA</a:t>
+              <a:t>PROVIDER SUPPORT</a:t>
             </a:r>
             <a:endParaRPr lang="en-US" sz="1193" dirty="0"/>
           </a:p>
@@ -9840,7 +9884,7 @@
                 <a:ea typeface="Inter" pitchFamily="34" charset="-122"/>
                 <a:cs typeface="Inter" pitchFamily="34" charset="-120"/>
               </a:rPr>
-              <a:t>: Full multi-agent </a:t>
+              <a:t>: Tier 1 primary, </a:t>
             </a:r>
             <a:pPr algn="l" indent="0" marL="0">
               <a:lnSpc>
@@ -9857,7 +9901,7 @@
                 <a:ea typeface="Inter" pitchFamily="34" charset="-122"/>
                 <a:cs typeface="Inter" pitchFamily="34" charset="-120"/>
               </a:rPr>
-              <a:t>parallel support</a:t>
+              <a:t>E2E-verified</a:t>
             </a:r>
             <a:endParaRPr lang="en-US" sz="784" dirty="0"/>
           </a:p>
@@ -9925,7 +9969,7 @@
                 <a:ea typeface="JetBrains Mono" pitchFamily="34" charset="-122"/>
                 <a:cs typeface="JetBrains Mono" pitchFamily="34" charset="-120"/>
               </a:rPr>
-              <a:t>Cline CLI</a:t>
+              <a:t>Cline</a:t>
             </a:r>
             <a:pPr algn="l" indent="0" marL="0">
               <a:lnSpc>
@@ -9942,7 +9986,7 @@
                 <a:ea typeface="Inter" pitchFamily="34" charset="-122"/>
                 <a:cs typeface="Inter" pitchFamily="34" charset="-120"/>
               </a:rPr>
-              <a:t>: Near-full </a:t>
+              <a:t>: Experimental </a:t>
             </a:r>
             <a:pPr algn="l" indent="0" marL="0">
               <a:lnSpc>
@@ -9959,7 +10003,7 @@
                 <a:ea typeface="Inter" pitchFamily="34" charset="-122"/>
                 <a:cs typeface="Inter" pitchFamily="34" charset="-120"/>
               </a:rPr>
-              <a:t>subagent/MCP support</a:t>
+              <a:t>provider</a:t>
             </a:r>
             <a:endParaRPr lang="en-US" sz="784" dirty="0"/>
           </a:p>
@@ -10044,7 +10088,7 @@
                 <a:ea typeface="Inter" pitchFamily="34" charset="-122"/>
                 <a:cs typeface="Inter" pitchFamily="34" charset="-120"/>
               </a:rPr>
-              <a:t>: 18+ model provider </a:t>
+              <a:t>: Experimental, </a:t>
             </a:r>
             <a:pPr algn="l" indent="0" marL="0">
               <a:lnSpc>
@@ -10061,7 +10105,7 @@
                 <a:ea typeface="Inter" pitchFamily="34" charset="-122"/>
                 <a:cs typeface="Inter" pitchFamily="34" charset="-120"/>
               </a:rPr>
-              <a:t>support</a:t>
+              <a:t>18+ models</a:t>
             </a:r>
             <a:endParaRPr lang="en-US" sz="784" dirty="0"/>
           </a:p>
@@ -10146,7 +10190,7 @@
                 <a:ea typeface="Inter" pitchFamily="34" charset="-122"/>
                 <a:cs typeface="Inter" pitchFamily="34" charset="-120"/>
               </a:rPr>
-              <a:t>: Sequential </a:t>
+              <a:t>: Experimental </a:t>
             </a:r>
             <a:pPr algn="l" indent="0" marL="0">
               <a:lnSpc>
@@ -10163,7 +10207,7 @@
                 <a:ea typeface="Inter" pitchFamily="34" charset="-122"/>
                 <a:cs typeface="Inter" pitchFamily="34" charset="-120"/>
               </a:rPr>
-              <a:t>execution</a:t>
+              <a:t>provider</a:t>
             </a:r>
             <a:endParaRPr lang="en-US" sz="784" dirty="0"/>
           </a:p>
@@ -14471,7 +14515,7 @@
                 <a:ea typeface="Inter" pitchFamily="34" charset="-122"/>
                 <a:cs typeface="Inter" pitchFamily="34" charset="-120"/>
               </a:rPr>
-              <a:t>Why Loki Mode is Better (v7.24.0)</a:t>
+              <a:t>Why Loki Mode is Better (v7.26.0)</a:t>
             </a:r>
             <a:endParaRPr lang="en-US" sz="2436" dirty="0"/>
           </a:p>
@@ -15141,7 +15185,7 @@
                 <a:ea typeface="Inter" pitchFamily="34" charset="-122"/>
                 <a:cs typeface="Inter" pitchFamily="34" charset="-120"/>
               </a:rPr>
-              <a:t>41 Agents + Recursive Sub-Planning</a:t>
+              <a:t>41 Agent Roles + Recursive Sub-Planning</a:t>
             </a:r>
             <a:endParaRPr lang="en-US" sz="885" dirty="0"/>
           </a:p>

</xml_diff>